<commit_message>
some enhancements on testing proportions
</commit_message>
<xml_diff>
--- a/Part 2 - Inferential Statisitcs/Part 2.2 - Introduction to Estimation in Statistics/Part 2.2 - Introduction to Estimation in Statistics.pptx
+++ b/Part 2 - Inferential Statisitcs/Part 2.2 - Introduction to Estimation in Statistics/Part 2.2 - Introduction to Estimation in Statistics.pptx
@@ -140,6 +140,14 @@
 </p:cmAuthorLst>
 </file>
 
+<file path=ppt/revisionInfo.xml><?xml version="1.0" encoding="utf-8"?>
+<p1510:revInfo xmlns:a="http://schemas.openxmlformats.org/drawingml/2006/main" xmlns:r="http://schemas.openxmlformats.org/officeDocument/2006/relationships" xmlns:p1510="http://schemas.microsoft.com/office/powerpoint/2015/10/main">
+  <p1510:revLst>
+    <p1510:client id="{63DC8870-DB6C-438B-8070-11A8FA504ECC}" v="1" dt="2025-05-17T14:18:37.241"/>
+  </p1510:revLst>
+</p1510:revInfo>
+</file>
+
 <file path=ppt/changesInfos/changesInfo1.xml><?xml version="1.0" encoding="utf-8"?>
 <pc:chgInfo xmlns:a="http://schemas.openxmlformats.org/drawingml/2006/main" xmlns:r="http://schemas.openxmlformats.org/officeDocument/2006/relationships" xmlns:ac="http://schemas.microsoft.com/office/drawing/2013/main/command" xmlns:pc="http://schemas.microsoft.com/office/powerpoint/2013/main/command">
   <pc:docChgLst>
@@ -161,10 +169,17 @@
   <pc:docChgLst>
     <pc:chgData name="Mohammed Fasha" userId="cc64f42d-a1a6-4f08-b97b-0c37f877119f" providerId="ADAL" clId="{63DC8870-DB6C-438B-8070-11A8FA504ECC}"/>
     <pc:docChg chg="undo custSel delSld modSld">
-      <pc:chgData name="Mohammed Fasha" userId="cc64f42d-a1a6-4f08-b97b-0c37f877119f" providerId="ADAL" clId="{63DC8870-DB6C-438B-8070-11A8FA504ECC}" dt="2025-05-16T05:58:26.814" v="101" actId="20577"/>
+      <pc:chgData name="Mohammed Fasha" userId="cc64f42d-a1a6-4f08-b97b-0c37f877119f" providerId="ADAL" clId="{63DC8870-DB6C-438B-8070-11A8FA504ECC}" dt="2025-05-17T14:18:37.241" v="102"/>
       <pc:docMkLst>
         <pc:docMk/>
       </pc:docMkLst>
+      <pc:sldChg chg="modTransition">
+        <pc:chgData name="Mohammed Fasha" userId="cc64f42d-a1a6-4f08-b97b-0c37f877119f" providerId="ADAL" clId="{63DC8870-DB6C-438B-8070-11A8FA504ECC}" dt="2025-05-17T14:18:37.241" v="102"/>
+        <pc:sldMkLst>
+          <pc:docMk/>
+          <pc:sldMk cId="607684796" sldId="333"/>
+        </pc:sldMkLst>
+      </pc:sldChg>
       <pc:sldChg chg="del">
         <pc:chgData name="Mohammed Fasha" userId="cc64f42d-a1a6-4f08-b97b-0c37f877119f" providerId="ADAL" clId="{63DC8870-DB6C-438B-8070-11A8FA504ECC}" dt="2025-05-16T05:44:58.934" v="2" actId="47"/>
         <pc:sldMkLst>
@@ -193,6 +208,13 @@
           <pc:sldMk cId="1852804652" sldId="396"/>
         </pc:sldMkLst>
       </pc:sldChg>
+      <pc:sldChg chg="modTransition">
+        <pc:chgData name="Mohammed Fasha" userId="cc64f42d-a1a6-4f08-b97b-0c37f877119f" providerId="ADAL" clId="{63DC8870-DB6C-438B-8070-11A8FA504ECC}" dt="2025-05-17T14:18:37.241" v="102"/>
+        <pc:sldMkLst>
+          <pc:docMk/>
+          <pc:sldMk cId="587789057" sldId="423"/>
+        </pc:sldMkLst>
+      </pc:sldChg>
       <pc:sldChg chg="del">
         <pc:chgData name="Mohammed Fasha" userId="cc64f42d-a1a6-4f08-b97b-0c37f877119f" providerId="ADAL" clId="{63DC8870-DB6C-438B-8070-11A8FA504ECC}" dt="2025-05-16T05:44:58.934" v="2" actId="47"/>
         <pc:sldMkLst>
@@ -200,6 +222,34 @@
           <pc:sldMk cId="1625691186" sldId="425"/>
         </pc:sldMkLst>
       </pc:sldChg>
+      <pc:sldChg chg="modTransition">
+        <pc:chgData name="Mohammed Fasha" userId="cc64f42d-a1a6-4f08-b97b-0c37f877119f" providerId="ADAL" clId="{63DC8870-DB6C-438B-8070-11A8FA504ECC}" dt="2025-05-17T14:18:37.241" v="102"/>
+        <pc:sldMkLst>
+          <pc:docMk/>
+          <pc:sldMk cId="2127906749" sldId="427"/>
+        </pc:sldMkLst>
+      </pc:sldChg>
+      <pc:sldChg chg="modTransition">
+        <pc:chgData name="Mohammed Fasha" userId="cc64f42d-a1a6-4f08-b97b-0c37f877119f" providerId="ADAL" clId="{63DC8870-DB6C-438B-8070-11A8FA504ECC}" dt="2025-05-17T14:18:37.241" v="102"/>
+        <pc:sldMkLst>
+          <pc:docMk/>
+          <pc:sldMk cId="391491219" sldId="428"/>
+        </pc:sldMkLst>
+      </pc:sldChg>
+      <pc:sldChg chg="modTransition">
+        <pc:chgData name="Mohammed Fasha" userId="cc64f42d-a1a6-4f08-b97b-0c37f877119f" providerId="ADAL" clId="{63DC8870-DB6C-438B-8070-11A8FA504ECC}" dt="2025-05-17T14:18:37.241" v="102"/>
+        <pc:sldMkLst>
+          <pc:docMk/>
+          <pc:sldMk cId="3339445507" sldId="430"/>
+        </pc:sldMkLst>
+      </pc:sldChg>
+      <pc:sldChg chg="modTransition">
+        <pc:chgData name="Mohammed Fasha" userId="cc64f42d-a1a6-4f08-b97b-0c37f877119f" providerId="ADAL" clId="{63DC8870-DB6C-438B-8070-11A8FA504ECC}" dt="2025-05-17T14:18:37.241" v="102"/>
+        <pc:sldMkLst>
+          <pc:docMk/>
+          <pc:sldMk cId="3389046835" sldId="431"/>
+        </pc:sldMkLst>
+      </pc:sldChg>
       <pc:sldChg chg="del">
         <pc:chgData name="Mohammed Fasha" userId="cc64f42d-a1a6-4f08-b97b-0c37f877119f" providerId="ADAL" clId="{63DC8870-DB6C-438B-8070-11A8FA504ECC}" dt="2025-05-16T05:44:58.934" v="2" actId="47"/>
         <pc:sldMkLst>
@@ -221,8 +271,8 @@
           <pc:sldMk cId="2905491798" sldId="440"/>
         </pc:sldMkLst>
       </pc:sldChg>
-      <pc:sldChg chg="modSp mod">
-        <pc:chgData name="Mohammed Fasha" userId="cc64f42d-a1a6-4f08-b97b-0c37f877119f" providerId="ADAL" clId="{63DC8870-DB6C-438B-8070-11A8FA504ECC}" dt="2025-05-16T05:58:26.814" v="101" actId="20577"/>
+      <pc:sldChg chg="modSp mod modTransition">
+        <pc:chgData name="Mohammed Fasha" userId="cc64f42d-a1a6-4f08-b97b-0c37f877119f" providerId="ADAL" clId="{63DC8870-DB6C-438B-8070-11A8FA504ECC}" dt="2025-05-17T14:18:37.241" v="102"/>
         <pc:sldMkLst>
           <pc:docMk/>
           <pc:sldMk cId="4208461039" sldId="447"/>
@@ -250,8 +300,8 @@
           <pc:sldMk cId="2726994946" sldId="479"/>
         </pc:sldMkLst>
       </pc:sldChg>
-      <pc:sldChg chg="modSp mod">
-        <pc:chgData name="Mohammed Fasha" userId="cc64f42d-a1a6-4f08-b97b-0c37f877119f" providerId="ADAL" clId="{63DC8870-DB6C-438B-8070-11A8FA504ECC}" dt="2025-05-16T05:56:12.898" v="7" actId="20577"/>
+      <pc:sldChg chg="modSp mod modTransition">
+        <pc:chgData name="Mohammed Fasha" userId="cc64f42d-a1a6-4f08-b97b-0c37f877119f" providerId="ADAL" clId="{63DC8870-DB6C-438B-8070-11A8FA504ECC}" dt="2025-05-17T14:18:37.241" v="102"/>
         <pc:sldMkLst>
           <pc:docMk/>
           <pc:sldMk cId="2297456757" sldId="483"/>
@@ -391,6 +441,69 @@
           <pc:sldMk cId="4283467534" sldId="604"/>
         </pc:sldMkLst>
       </pc:sldChg>
+      <pc:sldChg chg="modTransition">
+        <pc:chgData name="Mohammed Fasha" userId="cc64f42d-a1a6-4f08-b97b-0c37f877119f" providerId="ADAL" clId="{63DC8870-DB6C-438B-8070-11A8FA504ECC}" dt="2025-05-17T14:18:37.241" v="102"/>
+        <pc:sldMkLst>
+          <pc:docMk/>
+          <pc:sldMk cId="2877973779" sldId="607"/>
+        </pc:sldMkLst>
+      </pc:sldChg>
+      <pc:sldChg chg="modTransition">
+        <pc:chgData name="Mohammed Fasha" userId="cc64f42d-a1a6-4f08-b97b-0c37f877119f" providerId="ADAL" clId="{63DC8870-DB6C-438B-8070-11A8FA504ECC}" dt="2025-05-17T14:18:37.241" v="102"/>
+        <pc:sldMkLst>
+          <pc:docMk/>
+          <pc:sldMk cId="21481256" sldId="611"/>
+        </pc:sldMkLst>
+      </pc:sldChg>
+      <pc:sldChg chg="modTransition">
+        <pc:chgData name="Mohammed Fasha" userId="cc64f42d-a1a6-4f08-b97b-0c37f877119f" providerId="ADAL" clId="{63DC8870-DB6C-438B-8070-11A8FA504ECC}" dt="2025-05-17T14:18:37.241" v="102"/>
+        <pc:sldMkLst>
+          <pc:docMk/>
+          <pc:sldMk cId="4040874025" sldId="612"/>
+        </pc:sldMkLst>
+      </pc:sldChg>
+      <pc:sldChg chg="modTransition">
+        <pc:chgData name="Mohammed Fasha" userId="cc64f42d-a1a6-4f08-b97b-0c37f877119f" providerId="ADAL" clId="{63DC8870-DB6C-438B-8070-11A8FA504ECC}" dt="2025-05-17T14:18:37.241" v="102"/>
+        <pc:sldMkLst>
+          <pc:docMk/>
+          <pc:sldMk cId="399592497" sldId="613"/>
+        </pc:sldMkLst>
+      </pc:sldChg>
+      <pc:sldChg chg="modTransition">
+        <pc:chgData name="Mohammed Fasha" userId="cc64f42d-a1a6-4f08-b97b-0c37f877119f" providerId="ADAL" clId="{63DC8870-DB6C-438B-8070-11A8FA504ECC}" dt="2025-05-17T14:18:37.241" v="102"/>
+        <pc:sldMkLst>
+          <pc:docMk/>
+          <pc:sldMk cId="3535314737" sldId="614"/>
+        </pc:sldMkLst>
+      </pc:sldChg>
+      <pc:sldChg chg="modTransition">
+        <pc:chgData name="Mohammed Fasha" userId="cc64f42d-a1a6-4f08-b97b-0c37f877119f" providerId="ADAL" clId="{63DC8870-DB6C-438B-8070-11A8FA504ECC}" dt="2025-05-17T14:18:37.241" v="102"/>
+        <pc:sldMkLst>
+          <pc:docMk/>
+          <pc:sldMk cId="627652750" sldId="615"/>
+        </pc:sldMkLst>
+      </pc:sldChg>
+      <pc:sldChg chg="modTransition">
+        <pc:chgData name="Mohammed Fasha" userId="cc64f42d-a1a6-4f08-b97b-0c37f877119f" providerId="ADAL" clId="{63DC8870-DB6C-438B-8070-11A8FA504ECC}" dt="2025-05-17T14:18:37.241" v="102"/>
+        <pc:sldMkLst>
+          <pc:docMk/>
+          <pc:sldMk cId="423212581" sldId="616"/>
+        </pc:sldMkLst>
+      </pc:sldChg>
+      <pc:sldChg chg="modTransition">
+        <pc:chgData name="Mohammed Fasha" userId="cc64f42d-a1a6-4f08-b97b-0c37f877119f" providerId="ADAL" clId="{63DC8870-DB6C-438B-8070-11A8FA504ECC}" dt="2025-05-17T14:18:37.241" v="102"/>
+        <pc:sldMkLst>
+          <pc:docMk/>
+          <pc:sldMk cId="3329135496" sldId="617"/>
+        </pc:sldMkLst>
+      </pc:sldChg>
+      <pc:sldChg chg="modTransition">
+        <pc:chgData name="Mohammed Fasha" userId="cc64f42d-a1a6-4f08-b97b-0c37f877119f" providerId="ADAL" clId="{63DC8870-DB6C-438B-8070-11A8FA504ECC}" dt="2025-05-17T14:18:37.241" v="102"/>
+        <pc:sldMkLst>
+          <pc:docMk/>
+          <pc:sldMk cId="1380276415" sldId="618"/>
+        </pc:sldMkLst>
+      </pc:sldChg>
       <pc:sldChg chg="del">
         <pc:chgData name="Mohammed Fasha" userId="cc64f42d-a1a6-4f08-b97b-0c37f877119f" providerId="ADAL" clId="{63DC8870-DB6C-438B-8070-11A8FA504ECC}" dt="2025-05-16T05:45:10.893" v="4" actId="47"/>
         <pc:sldMkLst>
@@ -447,6 +560,13 @@
           <pc:sldMk cId="1135291414" sldId="643"/>
         </pc:sldMkLst>
       </pc:sldChg>
+      <pc:sldChg chg="modTransition">
+        <pc:chgData name="Mohammed Fasha" userId="cc64f42d-a1a6-4f08-b97b-0c37f877119f" providerId="ADAL" clId="{63DC8870-DB6C-438B-8070-11A8FA504ECC}" dt="2025-05-17T14:18:37.241" v="102"/>
+        <pc:sldMkLst>
+          <pc:docMk/>
+          <pc:sldMk cId="1030124935" sldId="644"/>
+        </pc:sldMkLst>
+      </pc:sldChg>
       <pc:sldChg chg="del">
         <pc:chgData name="Mohammed Fasha" userId="cc64f42d-a1a6-4f08-b97b-0c37f877119f" providerId="ADAL" clId="{63DC8870-DB6C-438B-8070-11A8FA504ECC}" dt="2025-05-16T05:45:10.893" v="4" actId="47"/>
         <pc:sldMkLst>
@@ -734,6 +854,13 @@
           <pc:sldMk cId="1982708772" sldId="692"/>
         </pc:sldMkLst>
       </pc:sldChg>
+      <pc:sldChg chg="modTransition">
+        <pc:chgData name="Mohammed Fasha" userId="cc64f42d-a1a6-4f08-b97b-0c37f877119f" providerId="ADAL" clId="{63DC8870-DB6C-438B-8070-11A8FA504ECC}" dt="2025-05-17T14:18:37.241" v="102"/>
+        <pc:sldMkLst>
+          <pc:docMk/>
+          <pc:sldMk cId="3424197979" sldId="694"/>
+        </pc:sldMkLst>
+      </pc:sldChg>
       <pc:sldChg chg="del">
         <pc:chgData name="Mohammed Fasha" userId="cc64f42d-a1a6-4f08-b97b-0c37f877119f" providerId="ADAL" clId="{63DC8870-DB6C-438B-8070-11A8FA504ECC}" dt="2025-05-16T05:45:10.893" v="4" actId="47"/>
         <pc:sldMkLst>
@@ -907,6 +1034,13 @@
         <pc:sldMkLst>
           <pc:docMk/>
           <pc:sldMk cId="3056700689" sldId="724"/>
+        </pc:sldMkLst>
+      </pc:sldChg>
+      <pc:sldChg chg="modTransition">
+        <pc:chgData name="Mohammed Fasha" userId="cc64f42d-a1a6-4f08-b97b-0c37f877119f" providerId="ADAL" clId="{63DC8870-DB6C-438B-8070-11A8FA504ECC}" dt="2025-05-17T14:18:37.241" v="102"/>
+        <pc:sldMkLst>
+          <pc:docMk/>
+          <pc:sldMk cId="2280465272" sldId="725"/>
         </pc:sldMkLst>
       </pc:sldChg>
       <pc:sldChg chg="del">
@@ -1956,7 +2090,7 @@
           <a:p>
             <a:fld id="{13BA03A4-B9F1-404C-8A74-B1AFD6480953}" type="datetimeFigureOut">
               <a:rPr lang="en-US" smtClean="0"/>
-              <a:t>5/16/2025</a:t>
+              <a:t>5/17/2025</a:t>
             </a:fld>
             <a:endParaRPr lang="en-US"/>
           </a:p>
@@ -2538,7 +2672,7 @@
           <a:p>
             <a:fld id="{0DB78E95-DE77-44D3-BDB9-E242948FB112}" type="datetimeFigureOut">
               <a:rPr lang="en-US" smtClean="0"/>
-              <a:t>5/16/2025</a:t>
+              <a:t>5/17/2025</a:t>
             </a:fld>
             <a:endParaRPr lang="en-US"/>
           </a:p>
@@ -2766,7 +2900,7 @@
           <a:p>
             <a:fld id="{0DB78E95-DE77-44D3-BDB9-E242948FB112}" type="datetimeFigureOut">
               <a:rPr lang="en-US" smtClean="0"/>
-              <a:t>5/16/2025</a:t>
+              <a:t>5/17/2025</a:t>
             </a:fld>
             <a:endParaRPr lang="en-US"/>
           </a:p>
@@ -2974,7 +3108,7 @@
           <a:p>
             <a:fld id="{0DB78E95-DE77-44D3-BDB9-E242948FB112}" type="datetimeFigureOut">
               <a:rPr lang="en-US" smtClean="0"/>
-              <a:t>5/16/2025</a:t>
+              <a:t>5/17/2025</a:t>
             </a:fld>
             <a:endParaRPr lang="en-US"/>
           </a:p>
@@ -3405,7 +3539,7 @@
           <a:p>
             <a:fld id="{0DB78E95-DE77-44D3-BDB9-E242948FB112}" type="datetimeFigureOut">
               <a:rPr lang="en-US" smtClean="0"/>
-              <a:t>5/16/2025</a:t>
+              <a:t>5/17/2025</a:t>
             </a:fld>
             <a:endParaRPr lang="en-US"/>
           </a:p>
@@ -3784,7 +3918,7 @@
           <a:p>
             <a:fld id="{0DB78E95-DE77-44D3-BDB9-E242948FB112}" type="datetimeFigureOut">
               <a:rPr lang="en-US" smtClean="0"/>
-              <a:t>5/16/2025</a:t>
+              <a:t>5/17/2025</a:t>
             </a:fld>
             <a:endParaRPr lang="en-US"/>
           </a:p>
@@ -4196,7 +4330,7 @@
           <a:p>
             <a:fld id="{0DB78E95-DE77-44D3-BDB9-E242948FB112}" type="datetimeFigureOut">
               <a:rPr lang="en-US" smtClean="0"/>
-              <a:t>5/16/2025</a:t>
+              <a:t>5/17/2025</a:t>
             </a:fld>
             <a:endParaRPr lang="en-US"/>
           </a:p>
@@ -4337,7 +4471,7 @@
           <a:p>
             <a:fld id="{0DB78E95-DE77-44D3-BDB9-E242948FB112}" type="datetimeFigureOut">
               <a:rPr lang="en-US" smtClean="0"/>
-              <a:t>5/16/2025</a:t>
+              <a:t>5/17/2025</a:t>
             </a:fld>
             <a:endParaRPr lang="en-US"/>
           </a:p>
@@ -4450,7 +4584,7 @@
           <a:p>
             <a:fld id="{0DB78E95-DE77-44D3-BDB9-E242948FB112}" type="datetimeFigureOut">
               <a:rPr lang="en-US" smtClean="0"/>
-              <a:t>5/16/2025</a:t>
+              <a:t>5/17/2025</a:t>
             </a:fld>
             <a:endParaRPr lang="en-US"/>
           </a:p>
@@ -4761,7 +4895,7 @@
           <a:p>
             <a:fld id="{0DB78E95-DE77-44D3-BDB9-E242948FB112}" type="datetimeFigureOut">
               <a:rPr lang="en-US" smtClean="0"/>
-              <a:t>5/16/2025</a:t>
+              <a:t>5/17/2025</a:t>
             </a:fld>
             <a:endParaRPr lang="en-US"/>
           </a:p>
@@ -5049,7 +5183,7 @@
           <a:p>
             <a:fld id="{0DB78E95-DE77-44D3-BDB9-E242948FB112}" type="datetimeFigureOut">
               <a:rPr lang="en-US" smtClean="0"/>
-              <a:t>5/16/2025</a:t>
+              <a:t>5/17/2025</a:t>
             </a:fld>
             <a:endParaRPr lang="en-US"/>
           </a:p>
@@ -5290,7 +5424,7 @@
           <a:p>
             <a:fld id="{0DB78E95-DE77-44D3-BDB9-E242948FB112}" type="datetimeFigureOut">
               <a:rPr lang="en-US" smtClean="0"/>
-              <a:t>5/16/2025</a:t>
+              <a:t>5/17/2025</a:t>
             </a:fld>
             <a:endParaRPr lang="en-US"/>
           </a:p>
@@ -5904,18 +6038,9 @@
   <p:clrMapOvr>
     <a:masterClrMapping/>
   </p:clrMapOvr>
-  <mc:AlternateContent xmlns:mc="http://schemas.openxmlformats.org/markup-compatibility/2006" xmlns:p14="http://schemas.microsoft.com/office/powerpoint/2010/main">
-    <mc:Choice Requires="p14">
-      <p:transition spd="slow" p14:dur="1600">
-        <p14:conveyor dir="l"/>
-      </p:transition>
-    </mc:Choice>
-    <mc:Fallback xmlns="">
-      <p:transition spd="slow">
-        <p:fade/>
-      </p:transition>
-    </mc:Fallback>
-  </mc:AlternateContent>
+  <p:transition spd="med">
+    <p:pull/>
+  </p:transition>
 </p:sld>
 </file>
 
@@ -6252,18 +6377,9 @@
   <p:clrMapOvr>
     <a:masterClrMapping/>
   </p:clrMapOvr>
-  <mc:AlternateContent xmlns:mc="http://schemas.openxmlformats.org/markup-compatibility/2006" xmlns:p14="http://schemas.microsoft.com/office/powerpoint/2010/main">
-    <mc:Choice Requires="p14">
-      <p:transition spd="slow" p14:dur="1600">
-        <p14:conveyor dir="l"/>
-      </p:transition>
-    </mc:Choice>
-    <mc:Fallback xmlns="">
-      <p:transition spd="slow">
-        <p:fade/>
-      </p:transition>
-    </mc:Fallback>
-  </mc:AlternateContent>
+  <p:transition spd="med">
+    <p:pull/>
+  </p:transition>
 </p:sld>
 </file>
 
@@ -7590,6 +7706,9 @@
   <p:clrMapOvr>
     <a:masterClrMapping/>
   </p:clrMapOvr>
+  <p:transition spd="med">
+    <p:pull/>
+  </p:transition>
 </p:sld>
 </file>
 
@@ -7974,18 +8093,9 @@
   <p:clrMapOvr>
     <a:masterClrMapping/>
   </p:clrMapOvr>
-  <mc:AlternateContent xmlns:mc="http://schemas.openxmlformats.org/markup-compatibility/2006" xmlns:p14="http://schemas.microsoft.com/office/powerpoint/2010/main">
-    <mc:Choice Requires="p14">
-      <p:transition spd="slow" p14:dur="1600">
-        <p14:conveyor dir="l"/>
-      </p:transition>
-    </mc:Choice>
-    <mc:Fallback xmlns="">
-      <p:transition spd="slow">
-        <p:fade/>
-      </p:transition>
-    </mc:Fallback>
-  </mc:AlternateContent>
+  <p:transition spd="med">
+    <p:pull/>
+  </p:transition>
   <p:timing>
     <p:tnLst>
       <p:par>
@@ -8352,18 +8462,9 @@
   <p:clrMapOvr>
     <a:masterClrMapping/>
   </p:clrMapOvr>
-  <mc:AlternateContent xmlns:mc="http://schemas.openxmlformats.org/markup-compatibility/2006" xmlns:p14="http://schemas.microsoft.com/office/powerpoint/2010/main">
-    <mc:Choice Requires="p14">
-      <p:transition spd="slow" p14:dur="1600">
-        <p14:conveyor dir="l"/>
-      </p:transition>
-    </mc:Choice>
-    <mc:Fallback xmlns="">
-      <p:transition spd="slow">
-        <p:fade/>
-      </p:transition>
-    </mc:Fallback>
-  </mc:AlternateContent>
+  <p:transition spd="med">
+    <p:pull/>
+  </p:transition>
 </p:sld>
 </file>
 
@@ -8663,18 +8764,9 @@
   <p:clrMapOvr>
     <a:masterClrMapping/>
   </p:clrMapOvr>
-  <mc:AlternateContent xmlns:mc="http://schemas.openxmlformats.org/markup-compatibility/2006" xmlns:p14="http://schemas.microsoft.com/office/powerpoint/2010/main">
-    <mc:Choice Requires="p14">
-      <p:transition spd="slow" p14:dur="1600">
-        <p14:conveyor dir="l"/>
-      </p:transition>
-    </mc:Choice>
-    <mc:Fallback xmlns="">
-      <p:transition spd="slow">
-        <p:fade/>
-      </p:transition>
-    </mc:Fallback>
-  </mc:AlternateContent>
+  <p:transition spd="med">
+    <p:pull/>
+  </p:transition>
 </p:sld>
 </file>
 
@@ -8797,18 +8889,9 @@
   <p:clrMapOvr>
     <a:masterClrMapping/>
   </p:clrMapOvr>
-  <mc:AlternateContent xmlns:mc="http://schemas.openxmlformats.org/markup-compatibility/2006" xmlns:p14="http://schemas.microsoft.com/office/powerpoint/2010/main">
-    <mc:Choice Requires="p14">
-      <p:transition spd="slow" p14:dur="1600">
-        <p14:conveyor dir="l"/>
-      </p:transition>
-    </mc:Choice>
-    <mc:Fallback xmlns="">
-      <p:transition spd="slow">
-        <p:fade/>
-      </p:transition>
-    </mc:Fallback>
-  </mc:AlternateContent>
+  <p:transition spd="med">
+    <p:pull/>
+  </p:transition>
 </p:sld>
 </file>
 
@@ -9057,18 +9140,9 @@
   <p:clrMapOvr>
     <a:masterClrMapping/>
   </p:clrMapOvr>
-  <mc:AlternateContent xmlns:mc="http://schemas.openxmlformats.org/markup-compatibility/2006" xmlns:p14="http://schemas.microsoft.com/office/powerpoint/2010/main">
-    <mc:Choice Requires="p14">
-      <p:transition spd="slow" p14:dur="1600">
-        <p14:conveyor dir="l"/>
-      </p:transition>
-    </mc:Choice>
-    <mc:Fallback xmlns="">
-      <p:transition spd="slow">
-        <p:fade/>
-      </p:transition>
-    </mc:Fallback>
-  </mc:AlternateContent>
+  <p:transition spd="med">
+    <p:pull/>
+  </p:transition>
 </p:sld>
 </file>
 
@@ -9392,18 +9466,9 @@
   <p:clrMapOvr>
     <a:masterClrMapping/>
   </p:clrMapOvr>
-  <mc:AlternateContent xmlns:mc="http://schemas.openxmlformats.org/markup-compatibility/2006" xmlns:p14="http://schemas.microsoft.com/office/powerpoint/2010/main">
-    <mc:Choice Requires="p14">
-      <p:transition spd="slow" p14:dur="1600">
-        <p14:conveyor dir="l"/>
-      </p:transition>
-    </mc:Choice>
-    <mc:Fallback xmlns="">
-      <p:transition spd="slow">
-        <p:fade/>
-      </p:transition>
-    </mc:Fallback>
-  </mc:AlternateContent>
+  <p:transition spd="med">
+    <p:pull/>
+  </p:transition>
 </p:sld>
 </file>
 
@@ -9759,18 +9824,9 @@
   <p:clrMapOvr>
     <a:masterClrMapping/>
   </p:clrMapOvr>
-  <mc:AlternateContent xmlns:mc="http://schemas.openxmlformats.org/markup-compatibility/2006" xmlns:p14="http://schemas.microsoft.com/office/powerpoint/2010/main">
-    <mc:Choice Requires="p14">
-      <p:transition spd="slow" p14:dur="1600">
-        <p14:conveyor dir="l"/>
-      </p:transition>
-    </mc:Choice>
-    <mc:Fallback xmlns="">
-      <p:transition spd="slow">
-        <p:fade/>
-      </p:transition>
-    </mc:Fallback>
-  </mc:AlternateContent>
+  <p:transition spd="med">
+    <p:pull/>
+  </p:transition>
 </p:sld>
 </file>
 
@@ -10267,18 +10323,9 @@
   <p:clrMapOvr>
     <a:masterClrMapping/>
   </p:clrMapOvr>
-  <mc:AlternateContent xmlns:mc="http://schemas.openxmlformats.org/markup-compatibility/2006" xmlns:p14="http://schemas.microsoft.com/office/powerpoint/2010/main">
-    <mc:Choice Requires="p14">
-      <p:transition spd="slow" p14:dur="1600">
-        <p14:conveyor dir="l"/>
-      </p:transition>
-    </mc:Choice>
-    <mc:Fallback xmlns="">
-      <p:transition spd="slow">
-        <p:fade/>
-      </p:transition>
-    </mc:Fallback>
-  </mc:AlternateContent>
+  <p:transition spd="med">
+    <p:pull/>
+  </p:transition>
   <p:timing>
     <p:tnLst>
       <p:par>
@@ -10702,18 +10749,9 @@
   <p:clrMapOvr>
     <a:masterClrMapping/>
   </p:clrMapOvr>
-  <mc:AlternateContent xmlns:mc="http://schemas.openxmlformats.org/markup-compatibility/2006" xmlns:p14="http://schemas.microsoft.com/office/powerpoint/2010/main">
-    <mc:Choice Requires="p14">
-      <p:transition spd="slow" p14:dur="1600">
-        <p14:conveyor dir="l"/>
-      </p:transition>
-    </mc:Choice>
-    <mc:Fallback xmlns="">
-      <p:transition spd="slow">
-        <p:fade/>
-      </p:transition>
-    </mc:Fallback>
-  </mc:AlternateContent>
+  <p:transition spd="med">
+    <p:pull/>
+  </p:transition>
 </p:sld>
 </file>
 
@@ -11012,18 +11050,9 @@
   <p:clrMapOvr>
     <a:masterClrMapping/>
   </p:clrMapOvr>
-  <mc:AlternateContent xmlns:mc="http://schemas.openxmlformats.org/markup-compatibility/2006" xmlns:p14="http://schemas.microsoft.com/office/powerpoint/2010/main">
-    <mc:Choice Requires="p14">
-      <p:transition spd="slow" p14:dur="1600">
-        <p14:conveyor dir="l"/>
-      </p:transition>
-    </mc:Choice>
-    <mc:Fallback xmlns="">
-      <p:transition spd="slow">
-        <p:fade/>
-      </p:transition>
-    </mc:Fallback>
-  </mc:AlternateContent>
+  <p:transition spd="med">
+    <p:pull/>
+  </p:transition>
 </p:sld>
 </file>
 
@@ -11206,18 +11235,9 @@
   <p:clrMapOvr>
     <a:masterClrMapping/>
   </p:clrMapOvr>
-  <mc:AlternateContent xmlns:mc="http://schemas.openxmlformats.org/markup-compatibility/2006" xmlns:p14="http://schemas.microsoft.com/office/powerpoint/2010/main">
-    <mc:Choice Requires="p14">
-      <p:transition spd="slow" p14:dur="1600">
-        <p14:conveyor dir="l"/>
-      </p:transition>
-    </mc:Choice>
-    <mc:Fallback xmlns="">
-      <p:transition spd="slow">
-        <p:fade/>
-      </p:transition>
-    </mc:Fallback>
-  </mc:AlternateContent>
+  <p:transition spd="med">
+    <p:pull/>
+  </p:transition>
 </p:sld>
 </file>
 
@@ -11359,18 +11379,9 @@
   <p:clrMapOvr>
     <a:masterClrMapping/>
   </p:clrMapOvr>
-  <mc:AlternateContent xmlns:mc="http://schemas.openxmlformats.org/markup-compatibility/2006" xmlns:p14="http://schemas.microsoft.com/office/powerpoint/2010/main">
-    <mc:Choice Requires="p14">
-      <p:transition spd="slow" p14:dur="1600">
-        <p14:conveyor dir="l"/>
-      </p:transition>
-    </mc:Choice>
-    <mc:Fallback xmlns="">
-      <p:transition spd="slow">
-        <p:fade/>
-      </p:transition>
-    </mc:Fallback>
-  </mc:AlternateContent>
+  <p:transition spd="med">
+    <p:pull/>
+  </p:transition>
 </p:sld>
 </file>
 
@@ -11609,18 +11620,9 @@
   <p:clrMapOvr>
     <a:masterClrMapping/>
   </p:clrMapOvr>
-  <mc:AlternateContent xmlns:mc="http://schemas.openxmlformats.org/markup-compatibility/2006" xmlns:p14="http://schemas.microsoft.com/office/powerpoint/2010/main">
-    <mc:Choice Requires="p14">
-      <p:transition spd="slow" p14:dur="1600">
-        <p14:conveyor dir="l"/>
-      </p:transition>
-    </mc:Choice>
-    <mc:Fallback xmlns="">
-      <p:transition spd="slow">
-        <p:fade/>
-      </p:transition>
-    </mc:Fallback>
-  </mc:AlternateContent>
+  <p:transition spd="med">
+    <p:pull/>
+  </p:transition>
 </p:sld>
 </file>
 
@@ -11855,18 +11857,9 @@
   <p:clrMapOvr>
     <a:masterClrMapping/>
   </p:clrMapOvr>
-  <mc:AlternateContent xmlns:mc="http://schemas.openxmlformats.org/markup-compatibility/2006" xmlns:p14="http://schemas.microsoft.com/office/powerpoint/2010/main">
-    <mc:Choice Requires="p14">
-      <p:transition spd="slow" p14:dur="1600">
-        <p14:conveyor dir="l"/>
-      </p:transition>
-    </mc:Choice>
-    <mc:Fallback xmlns="">
-      <p:transition spd="slow">
-        <p:fade/>
-      </p:transition>
-    </mc:Fallback>
-  </mc:AlternateContent>
+  <p:transition spd="med">
+    <p:pull/>
+  </p:transition>
 </p:sld>
 </file>
 
@@ -12207,18 +12200,9 @@
   <p:clrMapOvr>
     <a:masterClrMapping/>
   </p:clrMapOvr>
-  <mc:AlternateContent xmlns:mc="http://schemas.openxmlformats.org/markup-compatibility/2006" xmlns:p14="http://schemas.microsoft.com/office/powerpoint/2010/main">
-    <mc:Choice Requires="p14">
-      <p:transition spd="slow" p14:dur="1600">
-        <p14:conveyor dir="l"/>
-      </p:transition>
-    </mc:Choice>
-    <mc:Fallback xmlns="">
-      <p:transition spd="slow">
-        <p:fade/>
-      </p:transition>
-    </mc:Fallback>
-  </mc:AlternateContent>
+  <p:transition spd="med">
+    <p:pull/>
+  </p:transition>
 </p:sld>
 </file>
 
@@ -12611,18 +12595,9 @@
   <p:clrMapOvr>
     <a:masterClrMapping/>
   </p:clrMapOvr>
-  <mc:AlternateContent xmlns:mc="http://schemas.openxmlformats.org/markup-compatibility/2006" xmlns:p14="http://schemas.microsoft.com/office/powerpoint/2010/main">
-    <mc:Choice Requires="p14">
-      <p:transition spd="slow" p14:dur="1600">
-        <p14:conveyor dir="l"/>
-      </p:transition>
-    </mc:Choice>
-    <mc:Fallback xmlns="">
-      <p:transition spd="slow">
-        <p:fade/>
-      </p:transition>
-    </mc:Fallback>
-  </mc:AlternateContent>
+  <p:transition spd="med">
+    <p:pull/>
+  </p:transition>
 </p:sld>
 </file>
 
@@ -12765,18 +12740,9 @@
   <p:clrMapOvr>
     <a:masterClrMapping/>
   </p:clrMapOvr>
-  <mc:AlternateContent xmlns:mc="http://schemas.openxmlformats.org/markup-compatibility/2006" xmlns:p14="http://schemas.microsoft.com/office/powerpoint/2010/main">
-    <mc:Choice Requires="p14">
-      <p:transition spd="slow" p14:dur="1600">
-        <p14:conveyor dir="l"/>
-      </p:transition>
-    </mc:Choice>
-    <mc:Fallback xmlns="">
-      <p:transition spd="slow">
-        <p:fade/>
-      </p:transition>
-    </mc:Fallback>
-  </mc:AlternateContent>
+  <p:transition spd="med">
+    <p:pull/>
+  </p:transition>
 </p:sld>
 </file>
 

</xml_diff>